<commit_message>
Regenerate pitch deck: new UI screenshots + scenario slide
Reflects the professional re-theme and decluttered sidebar (fresh workbench
screenshots) and adds a "Scenario toggle" slide showing the Escalation state
(Lau's gauge breached, queue re-ranked). 14 slides; validates clean.

Co-Authored-By: Claude Opus 4.8 <noreply@anthropic.com>
Claude-Session: https://claude.ai/code/session_01EFHb7TsHS5qFFAkQo5oV9K
</commit_message>
<xml_diff>
--- a/docs/pitch/Wealth-Intelligence-Pitch.pptx
+++ b/docs/pitch/Wealth-Intelligence-Pitch.pptx
@@ -18,9 +18,10 @@
     <p:sldId id="266" r:id="rId12"/>
     <p:sldId id="267" r:id="rId13"/>
     <p:sldId id="268" r:id="rId14"/>
+    <p:sldId id="269" r:id="rId15"/>
   </p:sldIdLst>
   <p:notesMasterIdLst>
-    <p:notesMasterId r:id="rId15"/>
+    <p:notesMasterId r:id="rId16"/>
   </p:notesMasterIdLst>
   <p:sldSz cx="12188952" cy="6858000"/>
   <p:notesSz cx="6858000" cy="12188952"/>
@@ -866,7 +867,7 @@
           <a:p>
             <a:r>
               <a:rPr lang="en-US" dirty="0"/>
-              <a:t>To close, the north star from the brief: build the intelligence layer between portfolio data and the Relationship Manager. That's exactly what we built — help RMs understand what matters, anticipate what's next, and turn complex portfolios into timely, personalised, trustworthy advice, with the RM kept central and owning every decision. What's next is a scenario toggle that re-prices exposures for a Middle-East escalation live, a one-page meeting-pack export, and household-level tax optimisation. Everything is synthetic, and the RM always owns the advice. Thank you.</a:t>
+              <a:t>The scenario toggle adds the 'what could happen next' half of the brief's flow. One control — De-escalation, Today, Escalation — re-prices every holding under a stylised shock vector grounded in the real 2026 moves. The demo moment: flip to Escalation and Lau's loan-to-value swings from 69.4% straight across the 70% margin call, the gauge goes red, and the whole book re-ranks by scenario stress so the newly-at-risk clients rise to the top. And it stays inside the governance boundary — the shocks and sensitivities are deterministic and shown on screen, never produced by the model. It's labelled an illustrative sensitivity, not a full risk engine, which is exactly the honest framing the brief rewards.</a:t>
             </a:r>
             <a:endParaRPr lang="en-US" dirty="0"/>
           </a:p>
@@ -890,6 +891,94 @@
             <a:fld id="{F7021451-1387-4CA6-816F-3879F97B5CBC}" type="slidenum">
               <a:rPr lang="en-US"/>
               <a:t>13</a:t>
+            </a:fld>
+            <a:endParaRPr lang="en-US"/>
+          </a:p>
+        </p:txBody>
+      </p:sp>
+    </p:spTree>
+    <p:extLst>
+      <p:ext uri="{BB962C8B-B14F-4D97-AF65-F5344CB8AC3E}">
+        <p14:creationId xmlns:p14="http://schemas.microsoft.com/office/powerpoint/2010/main" val="1024086991"/>
+      </p:ext>
+    </p:extLst>
+  </p:cSld>
+  <p:clrMapOvr>
+    <a:masterClrMapping/>
+  </p:clrMapOvr>
+</p:notes>
+</file>
+
+<file path=ppt/notesSlides/notesSlide14.xml><?xml version="1.0" encoding="utf-8"?>
+<p:notes xmlns:a="http://schemas.openxmlformats.org/drawingml/2006/main" xmlns:r="http://schemas.openxmlformats.org/officeDocument/2006/relationships" xmlns:p="http://schemas.openxmlformats.org/presentationml/2006/main">
+  <p:cSld>
+    <p:spTree>
+      <p:nvGrpSpPr>
+        <p:cNvPr id="1" name=""/>
+        <p:cNvGrpSpPr/>
+        <p:nvPr/>
+      </p:nvGrpSpPr>
+      <p:grpSpPr>
+        <a:xfrm>
+          <a:off x="0" y="0"/>
+          <a:ext cx="0" cy="0"/>
+          <a:chOff x="0" y="0"/>
+          <a:chExt cx="0" cy="0"/>
+        </a:xfrm>
+      </p:grpSpPr>
+      <p:sp>
+        <p:nvSpPr>
+          <p:cNvPr id="2" name="Slide Image Placeholder 1"/>
+          <p:cNvSpPr>
+            <a:spLocks noGrp="1" noRot="1" noChangeAspect="1"/>
+          </p:cNvSpPr>
+          <p:nvPr>
+            <p:ph type="sldImg"/>
+          </p:nvPr>
+        </p:nvSpPr>
+        <p:spPr/>
+      </p:sp>
+      <p:sp>
+        <p:nvSpPr>
+          <p:cNvPr id="3" name="Notes Placeholder 2"/>
+          <p:cNvSpPr>
+            <a:spLocks noGrp="1"/>
+          </p:cNvSpPr>
+          <p:nvPr>
+            <p:ph type="body" idx="1"/>
+          </p:nvPr>
+        </p:nvSpPr>
+        <p:spPr/>
+        <p:txBody>
+          <a:bodyPr/>
+          <a:lstStyle/>
+          <a:p>
+            <a:r>
+              <a:rPr lang="en-US" dirty="0"/>
+              <a:t>To close, the north star from the brief: build the intelligence layer between portfolio data and the Relationship Manager. That's exactly what we built — help RMs understand what matters, anticipate what's next, and turn complex portfolios into timely, personalised, trustworthy advice, with the RM kept central and owning every decision. What's next is a scenario toggle that re-prices exposures for a Middle-East escalation live, a one-page meeting-pack export, and household-level tax optimisation. Everything is synthetic, and the RM always owns the advice. Thank you.</a:t>
+            </a:r>
+            <a:endParaRPr lang="en-US" dirty="0"/>
+          </a:p>
+        </p:txBody>
+      </p:sp>
+      <p:sp>
+        <p:nvSpPr>
+          <p:cNvPr id="4" name="Slide Number Placeholder 3"/>
+          <p:cNvSpPr>
+            <a:spLocks noGrp="1"/>
+          </p:cNvSpPr>
+          <p:nvPr>
+            <p:ph type="sldNum" sz="quarter" idx="10"/>
+          </p:nvPr>
+        </p:nvSpPr>
+        <p:spPr/>
+        <p:txBody>
+          <a:bodyPr/>
+          <a:lstStyle/>
+          <a:p>
+            <a:fld id="{F7021451-1387-4CA6-816F-3879F97B5CBC}" type="slidenum">
+              <a:rPr lang="en-US"/>
+              <a:t>14</a:t>
             </a:fld>
             <a:endParaRPr lang="en-US"/>
           </a:p>
@@ -5389,6 +5478,557 @@
     <p:bg>
       <p:bgPr>
         <a:solidFill>
+          <a:srgbClr val="0C1320"/>
+        </a:solidFill>
+      </p:bgPr>
+    </p:bg>
+    <p:spTree>
+      <p:nvGrpSpPr>
+        <p:cNvPr id="1" name=""/>
+        <p:cNvGrpSpPr/>
+        <p:nvPr/>
+      </p:nvGrpSpPr>
+      <p:grpSpPr>
+        <a:xfrm>
+          <a:off x="0" y="0"/>
+          <a:ext cx="0" cy="0"/>
+          <a:chOff x="0" y="0"/>
+          <a:chExt cx="0" cy="0"/>
+        </a:xfrm>
+      </p:grpSpPr>
+      <p:sp>
+        <p:nvSpPr>
+          <p:cNvPr id="2" name="Text 0"/>
+          <p:cNvSpPr txBox="1"/>
+          <p:nvPr/>
+        </p:nvSpPr>
+        <p:spPr>
+          <a:xfrm>
+            <a:off x="566928" y="457200"/>
+            <a:ext cx="9144000" cy="274320"/>
+          </a:xfrm>
+          <a:prstGeom prst="rect">
+            <a:avLst/>
+          </a:prstGeom>
+          <a:noFill/>
+          <a:ln/>
+        </p:spPr>
+        <p:txBody>
+          <a:bodyPr wrap="square" lIns="0" tIns="0" rIns="0" bIns="0" rtlCol="0" anchor="ctr"/>
+          <a:lstStyle/>
+          <a:p>
+            <a:pPr indent="0" marL="0">
+              <a:buNone/>
+            </a:pPr>
+            <a:r>
+              <a:rPr lang="en-US" sz="1150" b="1" spc="300" kern="0" dirty="0">
+                <a:solidFill>
+                  <a:srgbClr val="C9A86A"/>
+                </a:solidFill>
+                <a:latin typeface="Calibri" pitchFamily="34" charset="0"/>
+                <a:ea typeface="Calibri" pitchFamily="34" charset="-122"/>
+                <a:cs typeface="Calibri" pitchFamily="34" charset="-120"/>
+              </a:rPr>
+              <a:t>HOW IT WORKS · WHAT COULD HAPPEN NEXT</a:t>
+            </a:r>
+            <a:endParaRPr lang="en-US" sz="1150" dirty="0"/>
+          </a:p>
+        </p:txBody>
+      </p:sp>
+      <p:sp>
+        <p:nvSpPr>
+          <p:cNvPr id="3" name="Text 1"/>
+          <p:cNvSpPr txBox="1"/>
+          <p:nvPr/>
+        </p:nvSpPr>
+        <p:spPr>
+          <a:xfrm>
+            <a:off x="548640" y="749808"/>
+            <a:ext cx="10972800" cy="914400"/>
+          </a:xfrm>
+          <a:prstGeom prst="rect">
+            <a:avLst/>
+          </a:prstGeom>
+          <a:noFill/>
+          <a:ln/>
+        </p:spPr>
+        <p:txBody>
+          <a:bodyPr wrap="square" lIns="0" tIns="0" rIns="0" bIns="0" rtlCol="0" anchor="ctr"/>
+          <a:lstStyle/>
+          <a:p>
+            <a:pPr indent="0" marL="0">
+              <a:lnSpc>
+                <a:spcPts val="3360"/>
+              </a:lnSpc>
+              <a:buNone/>
+            </a:pPr>
+            <a:r>
+              <a:rPr lang="en-US" sz="3200" b="1" dirty="0">
+                <a:solidFill>
+                  <a:srgbClr val="ECE7DD"/>
+                </a:solidFill>
+                <a:latin typeface="Cambria" pitchFamily="34" charset="0"/>
+                <a:ea typeface="Cambria" pitchFamily="34" charset="-122"/>
+                <a:cs typeface="Cambria" pitchFamily="34" charset="-120"/>
+              </a:rPr>
+              <a:t>Scenario toggle — forward-looking, still deterministic</a:t>
+            </a:r>
+            <a:endParaRPr lang="en-US" sz="3200" dirty="0"/>
+          </a:p>
+        </p:txBody>
+      </p:sp>
+      <p:pic>
+        <p:nvPicPr>
+          <p:cNvPr id="4" name="Image 0" descr="/tmp/claude-0/-home-user-juliusbaer/ce358b8c-70a4-5ca7-9728-984bd98dfdd2/scratchpad/deck_scenario.png">    </p:cNvPr>
+          <p:cNvPicPr>
+            <a:picLocks noChangeAspect="1"/>
+          </p:cNvPicPr>
+          <p:nvPr/>
+        </p:nvPicPr>
+        <p:blipFill>
+          <a:blip r:embed="rId1"/>
+          <a:stretch>
+            <a:fillRect/>
+          </a:stretch>
+        </p:blipFill>
+        <p:spPr>
+          <a:xfrm>
+            <a:off x="548640" y="1691640"/>
+            <a:ext cx="8412480" cy="5842000"/>
+          </a:xfrm>
+          <a:prstGeom prst="ellipse">
+            <a:avLst/>
+          </a:prstGeom>
+        </p:spPr>
+      </p:pic>
+      <p:sp>
+        <p:nvSpPr>
+          <p:cNvPr id="5" name="Text 2"/>
+          <p:cNvSpPr txBox="1"/>
+          <p:nvPr/>
+        </p:nvSpPr>
+        <p:spPr>
+          <a:xfrm>
+            <a:off x="9144000" y="1783080"/>
+            <a:ext cx="2697480" cy="457200"/>
+          </a:xfrm>
+          <a:prstGeom prst="rect">
+            <a:avLst/>
+          </a:prstGeom>
+          <a:noFill/>
+          <a:ln/>
+        </p:spPr>
+        <p:txBody>
+          <a:bodyPr wrap="square" lIns="0" tIns="0" rIns="0" bIns="0" rtlCol="0" anchor="ctr"/>
+          <a:lstStyle/>
+          <a:p>
+            <a:pPr indent="0" marL="0">
+              <a:lnSpc>
+                <a:spcPts val="1700"/>
+              </a:lnSpc>
+              <a:buNone/>
+            </a:pPr>
+            <a:r>
+              <a:rPr lang="en-US" sz="1400" b="1" dirty="0">
+                <a:solidFill>
+                  <a:srgbClr val="C9A86A"/>
+                </a:solidFill>
+                <a:latin typeface="Cambria" pitchFamily="34" charset="0"/>
+                <a:ea typeface="Cambria" pitchFamily="34" charset="-122"/>
+                <a:cs typeface="Cambria" pitchFamily="34" charset="-120"/>
+              </a:rPr>
+              <a:t>De-escalation · Today · Escalation</a:t>
+            </a:r>
+            <a:endParaRPr lang="en-US" sz="1400" dirty="0"/>
+          </a:p>
+        </p:txBody>
+      </p:sp>
+      <p:sp>
+        <p:nvSpPr>
+          <p:cNvPr id="6" name="Text 3"/>
+          <p:cNvSpPr txBox="1"/>
+          <p:nvPr/>
+        </p:nvSpPr>
+        <p:spPr>
+          <a:xfrm>
+            <a:off x="9144000" y="2286000"/>
+            <a:ext cx="2697480" cy="777240"/>
+          </a:xfrm>
+          <a:prstGeom prst="rect">
+            <a:avLst/>
+          </a:prstGeom>
+          <a:noFill/>
+          <a:ln/>
+        </p:spPr>
+        <p:txBody>
+          <a:bodyPr wrap="square" lIns="0" tIns="0" rIns="0" bIns="0" rtlCol="0" anchor="ctr"/>
+          <a:lstStyle/>
+          <a:p>
+            <a:pPr indent="0" marL="0">
+              <a:lnSpc>
+                <a:spcPts val="1500"/>
+              </a:lnSpc>
+              <a:buNone/>
+            </a:pPr>
+            <a:r>
+              <a:rPr lang="en-US" sz="1150" dirty="0">
+                <a:solidFill>
+                  <a:srgbClr val="A7ADBA"/>
+                </a:solidFill>
+                <a:latin typeface="Calibri" pitchFamily="34" charset="0"/>
+                <a:ea typeface="Calibri" pitchFamily="34" charset="-122"/>
+                <a:cs typeface="Calibri" pitchFamily="34" charset="-120"/>
+              </a:rPr>
+              <a:t>One toggle re-prices every holding under a market shock.</a:t>
+            </a:r>
+            <a:endParaRPr lang="en-US" sz="1150" dirty="0"/>
+          </a:p>
+        </p:txBody>
+      </p:sp>
+      <p:sp>
+        <p:nvSpPr>
+          <p:cNvPr id="7" name="Text 4"/>
+          <p:cNvSpPr txBox="1"/>
+          <p:nvPr/>
+        </p:nvSpPr>
+        <p:spPr>
+          <a:xfrm>
+            <a:off x="9144000" y="2953512"/>
+            <a:ext cx="2697480" cy="457200"/>
+          </a:xfrm>
+          <a:prstGeom prst="rect">
+            <a:avLst/>
+          </a:prstGeom>
+          <a:noFill/>
+          <a:ln/>
+        </p:spPr>
+        <p:txBody>
+          <a:bodyPr wrap="square" lIns="0" tIns="0" rIns="0" bIns="0" rtlCol="0" anchor="ctr"/>
+          <a:lstStyle/>
+          <a:p>
+            <a:pPr indent="0" marL="0">
+              <a:lnSpc>
+                <a:spcPts val="1700"/>
+              </a:lnSpc>
+              <a:buNone/>
+            </a:pPr>
+            <a:r>
+              <a:rPr lang="en-US" sz="1400" b="1" dirty="0">
+                <a:solidFill>
+                  <a:srgbClr val="C9A86A"/>
+                </a:solidFill>
+                <a:latin typeface="Cambria" pitchFamily="34" charset="0"/>
+                <a:ea typeface="Cambria" pitchFamily="34" charset="-122"/>
+                <a:cs typeface="Cambria" pitchFamily="34" charset="-120"/>
+              </a:rPr>
+              <a:t>The gauge crosses the line</a:t>
+            </a:r>
+            <a:endParaRPr lang="en-US" sz="1400" dirty="0"/>
+          </a:p>
+        </p:txBody>
+      </p:sp>
+      <p:sp>
+        <p:nvSpPr>
+          <p:cNvPr id="8" name="Text 5"/>
+          <p:cNvSpPr txBox="1"/>
+          <p:nvPr/>
+        </p:nvSpPr>
+        <p:spPr>
+          <a:xfrm>
+            <a:off x="9144000" y="3456432"/>
+            <a:ext cx="2697480" cy="777240"/>
+          </a:xfrm>
+          <a:prstGeom prst="rect">
+            <a:avLst/>
+          </a:prstGeom>
+          <a:noFill/>
+          <a:ln/>
+        </p:spPr>
+        <p:txBody>
+          <a:bodyPr wrap="square" lIns="0" tIns="0" rIns="0" bIns="0" rtlCol="0" anchor="ctr"/>
+          <a:lstStyle/>
+          <a:p>
+            <a:pPr indent="0" marL="0">
+              <a:lnSpc>
+                <a:spcPts val="1500"/>
+              </a:lnSpc>
+              <a:buNone/>
+            </a:pPr>
+            <a:r>
+              <a:rPr lang="en-US" sz="1150" dirty="0">
+                <a:solidFill>
+                  <a:srgbClr val="A7ADBA"/>
+                </a:solidFill>
+                <a:latin typeface="Calibri" pitchFamily="34" charset="0"/>
+                <a:ea typeface="Calibri" pitchFamily="34" charset="-122"/>
+                <a:cs typeface="Calibri" pitchFamily="34" charset="-120"/>
+              </a:rPr>
+              <a:t>Under Escalation, Lau's LTV 69.4% → 70.4% — margin call breached.</a:t>
+            </a:r>
+            <a:endParaRPr lang="en-US" sz="1150" dirty="0"/>
+          </a:p>
+        </p:txBody>
+      </p:sp>
+      <p:sp>
+        <p:nvSpPr>
+          <p:cNvPr id="9" name="Text 6"/>
+          <p:cNvSpPr txBox="1"/>
+          <p:nvPr/>
+        </p:nvSpPr>
+        <p:spPr>
+          <a:xfrm>
+            <a:off x="9144000" y="4123944"/>
+            <a:ext cx="2697480" cy="457200"/>
+          </a:xfrm>
+          <a:prstGeom prst="rect">
+            <a:avLst/>
+          </a:prstGeom>
+          <a:noFill/>
+          <a:ln/>
+        </p:spPr>
+        <p:txBody>
+          <a:bodyPr wrap="square" lIns="0" tIns="0" rIns="0" bIns="0" rtlCol="0" anchor="ctr"/>
+          <a:lstStyle/>
+          <a:p>
+            <a:pPr indent="0" marL="0">
+              <a:lnSpc>
+                <a:spcPts val="1700"/>
+              </a:lnSpc>
+              <a:buNone/>
+            </a:pPr>
+            <a:r>
+              <a:rPr lang="en-US" sz="1400" b="1" dirty="0">
+                <a:solidFill>
+                  <a:srgbClr val="C9A86A"/>
+                </a:solidFill>
+                <a:latin typeface="Cambria" pitchFamily="34" charset="0"/>
+                <a:ea typeface="Cambria" pitchFamily="34" charset="-122"/>
+                <a:cs typeface="Cambria" pitchFamily="34" charset="-120"/>
+              </a:rPr>
+              <a:t>The book re-ranks</a:t>
+            </a:r>
+            <a:endParaRPr lang="en-US" sz="1400" dirty="0"/>
+          </a:p>
+        </p:txBody>
+      </p:sp>
+      <p:sp>
+        <p:nvSpPr>
+          <p:cNvPr id="10" name="Text 7"/>
+          <p:cNvSpPr txBox="1"/>
+          <p:nvPr/>
+        </p:nvSpPr>
+        <p:spPr>
+          <a:xfrm>
+            <a:off x="9144000" y="4626864"/>
+            <a:ext cx="2697480" cy="777240"/>
+          </a:xfrm>
+          <a:prstGeom prst="rect">
+            <a:avLst/>
+          </a:prstGeom>
+          <a:noFill/>
+          <a:ln/>
+        </p:spPr>
+        <p:txBody>
+          <a:bodyPr wrap="square" lIns="0" tIns="0" rIns="0" bIns="0" rtlCol="0" anchor="ctr"/>
+          <a:lstStyle/>
+          <a:p>
+            <a:pPr indent="0" marL="0">
+              <a:lnSpc>
+                <a:spcPts val="1500"/>
+              </a:lnSpc>
+              <a:buNone/>
+            </a:pPr>
+            <a:r>
+              <a:rPr lang="en-US" sz="1150" dirty="0">
+                <a:solidFill>
+                  <a:srgbClr val="A7ADBA"/>
+                </a:solidFill>
+                <a:latin typeface="Calibri" pitchFamily="34" charset="0"/>
+                <a:ea typeface="Calibri" pitchFamily="34" charset="-122"/>
+                <a:cs typeface="Calibri" pitchFamily="34" charset="-120"/>
+              </a:rPr>
+              <a:t>Ordered by scenario stress; who is newly at risk rises to the top.</a:t>
+            </a:r>
+            <a:endParaRPr lang="en-US" sz="1150" dirty="0"/>
+          </a:p>
+        </p:txBody>
+      </p:sp>
+      <p:sp>
+        <p:nvSpPr>
+          <p:cNvPr id="11" name="Text 8"/>
+          <p:cNvSpPr txBox="1"/>
+          <p:nvPr/>
+        </p:nvSpPr>
+        <p:spPr>
+          <a:xfrm>
+            <a:off x="9144000" y="5294376"/>
+            <a:ext cx="2697480" cy="457200"/>
+          </a:xfrm>
+          <a:prstGeom prst="rect">
+            <a:avLst/>
+          </a:prstGeom>
+          <a:noFill/>
+          <a:ln/>
+        </p:spPr>
+        <p:txBody>
+          <a:bodyPr wrap="square" lIns="0" tIns="0" rIns="0" bIns="0" rtlCol="0" anchor="ctr"/>
+          <a:lstStyle/>
+          <a:p>
+            <a:pPr indent="0" marL="0">
+              <a:lnSpc>
+                <a:spcPts val="1700"/>
+              </a:lnSpc>
+              <a:buNone/>
+            </a:pPr>
+            <a:r>
+              <a:rPr lang="en-US" sz="1400" b="1" dirty="0">
+                <a:solidFill>
+                  <a:srgbClr val="C9A86A"/>
+                </a:solidFill>
+                <a:latin typeface="Cambria" pitchFamily="34" charset="0"/>
+                <a:ea typeface="Cambria" pitchFamily="34" charset="-122"/>
+                <a:cs typeface="Cambria" pitchFamily="34" charset="-120"/>
+              </a:rPr>
+              <a:t>Still auditable</a:t>
+            </a:r>
+            <a:endParaRPr lang="en-US" sz="1400" dirty="0"/>
+          </a:p>
+        </p:txBody>
+      </p:sp>
+      <p:sp>
+        <p:nvSpPr>
+          <p:cNvPr id="12" name="Text 9"/>
+          <p:cNvSpPr txBox="1"/>
+          <p:nvPr/>
+        </p:nvSpPr>
+        <p:spPr>
+          <a:xfrm>
+            <a:off x="9144000" y="5797296"/>
+            <a:ext cx="2697480" cy="777240"/>
+          </a:xfrm>
+          <a:prstGeom prst="rect">
+            <a:avLst/>
+          </a:prstGeom>
+          <a:noFill/>
+          <a:ln/>
+        </p:spPr>
+        <p:txBody>
+          <a:bodyPr wrap="square" lIns="0" tIns="0" rIns="0" bIns="0" rtlCol="0" anchor="ctr"/>
+          <a:lstStyle/>
+          <a:p>
+            <a:pPr indent="0" marL="0">
+              <a:lnSpc>
+                <a:spcPts val="1500"/>
+              </a:lnSpc>
+              <a:buNone/>
+            </a:pPr>
+            <a:r>
+              <a:rPr lang="en-US" sz="1150" dirty="0">
+                <a:solidFill>
+                  <a:srgbClr val="A7ADBA"/>
+                </a:solidFill>
+                <a:latin typeface="Calibri" pitchFamily="34" charset="0"/>
+                <a:ea typeface="Calibri" pitchFamily="34" charset="-122"/>
+                <a:cs typeface="Calibri" pitchFamily="34" charset="-120"/>
+              </a:rPr>
+              <a:t>The shock vector and sensitivities are computed and shown — never by the model.</a:t>
+            </a:r>
+            <a:endParaRPr lang="en-US" sz="1150" dirty="0"/>
+          </a:p>
+        </p:txBody>
+      </p:sp>
+      <p:sp>
+        <p:nvSpPr>
+          <p:cNvPr id="13" name="Text 10"/>
+          <p:cNvSpPr txBox="1"/>
+          <p:nvPr/>
+        </p:nvSpPr>
+        <p:spPr>
+          <a:xfrm>
+            <a:off x="548640" y="6473952"/>
+            <a:ext cx="7315200" cy="274320"/>
+          </a:xfrm>
+          <a:prstGeom prst="rect">
+            <a:avLst/>
+          </a:prstGeom>
+          <a:noFill/>
+          <a:ln/>
+        </p:spPr>
+        <p:txBody>
+          <a:bodyPr wrap="square" lIns="0" tIns="0" rIns="0" bIns="0" rtlCol="0" anchor="ctr"/>
+          <a:lstStyle/>
+          <a:p>
+            <a:pPr indent="0" marL="0">
+              <a:buNone/>
+            </a:pPr>
+            <a:r>
+              <a:rPr lang="en-US" sz="900" dirty="0">
+                <a:solidFill>
+                  <a:srgbClr val="7C8492"/>
+                </a:solidFill>
+                <a:latin typeface="Calibri" pitchFamily="34" charset="0"/>
+                <a:ea typeface="Calibri" pitchFamily="34" charset="-122"/>
+                <a:cs typeface="Calibri" pitchFamily="34" charset="-120"/>
+              </a:rPr>
+              <a:t>Wealth Intelligence · Julius Baer · Track #1</a:t>
+            </a:r>
+            <a:endParaRPr lang="en-US" sz="900" dirty="0"/>
+          </a:p>
+        </p:txBody>
+      </p:sp>
+      <p:sp>
+        <p:nvSpPr>
+          <p:cNvPr id="14" name="Text 11"/>
+          <p:cNvSpPr txBox="1"/>
+          <p:nvPr/>
+        </p:nvSpPr>
+        <p:spPr>
+          <a:xfrm>
+            <a:off x="11183112" y="6473952"/>
+            <a:ext cx="457200" cy="274320"/>
+          </a:xfrm>
+          <a:prstGeom prst="rect">
+            <a:avLst/>
+          </a:prstGeom>
+          <a:noFill/>
+          <a:ln/>
+        </p:spPr>
+        <p:txBody>
+          <a:bodyPr wrap="square" lIns="0" tIns="0" rIns="0" bIns="0" rtlCol="0" anchor="ctr"/>
+          <a:lstStyle/>
+          <a:p>
+            <a:pPr algn="r" indent="0" marL="0">
+              <a:buNone/>
+            </a:pPr>
+            <a:r>
+              <a:rPr lang="en-US" sz="900" dirty="0">
+                <a:solidFill>
+                  <a:srgbClr val="7C8492"/>
+                </a:solidFill>
+                <a:latin typeface="Calibri" pitchFamily="34" charset="0"/>
+                <a:ea typeface="Calibri" pitchFamily="34" charset="-122"/>
+                <a:cs typeface="Calibri" pitchFamily="34" charset="-120"/>
+              </a:rPr>
+              <a:t>13</a:t>
+            </a:r>
+            <a:endParaRPr lang="en-US" sz="900" dirty="0"/>
+          </a:p>
+        </p:txBody>
+      </p:sp>
+    </p:spTree>
+  </p:cSld>
+  <p:clrMapOvr>
+    <a:masterClrMapping/>
+  </p:clrMapOvr>
+</p:sld>
+</file>
+
+<file path=ppt/slides/slide14.xml><?xml version="1.0" encoding="utf-8"?>
+<p:sld xmlns:a="http://schemas.openxmlformats.org/drawingml/2006/main" xmlns:r="http://schemas.openxmlformats.org/officeDocument/2006/relationships" xmlns:p="http://schemas.openxmlformats.org/presentationml/2006/main">
+  <p:cSld name="Slide 14">
+    <p:bg>
+      <p:bgPr>
+        <a:solidFill>
           <a:srgbClr val="0A111C"/>
         </a:solidFill>
       </p:bgPr>
@@ -5673,7 +6313,7 @@
                 <a:ea typeface="Calibri" pitchFamily="34" charset="-122"/>
                 <a:cs typeface="Calibri" pitchFamily="34" charset="-120"/>
               </a:rPr>
-              <a:t>Scenario toggle (Middle East escalate / de-escalate, re-pricing exposures live)  ·  one-page meeting pack export  ·  household-level tax-lot optimisation</a:t>
+              <a:t>One-page meeting-pack export  ·  household-level tax-lot optimisation  ·  right-sizing the engine to a columnar store behind the same detector interface</a:t>
             </a:r>
             <a:endParaRPr lang="en-US" sz="1300" dirty="0"/>
           </a:p>

</xml_diff>